<commit_message>
all the code changes with real image update
</commit_message>
<xml_diff>
--- a/docs/DevGuardian_Prototype_Submission.pptx
+++ b/docs/DevGuardian_Prototype_Submission.pptx
@@ -9250,7 +9250,7 @@
                 <a:ea typeface="Segoe UI" pitchFamily="34" charset="-122"/>
                 <a:cs typeface="Segoe UI" pitchFamily="34" charset="-120"/>
               </a:rPr>
-              <a:t>Paste your recorded walkthrough link here before submitting:</a:t>
+              <a:t>Watch the full demo walkthrough (~3.5 min):</a:t>
             </a:r>
             <a:endParaRPr lang="en-US" sz="1100" dirty="0"/>
           </a:p>
@@ -9316,7 +9316,7 @@
                 <a:ea typeface="Segoe UI Semibold" pitchFamily="34" charset="-122"/>
                 <a:cs typeface="Segoe UI Semibold" pitchFamily="34" charset="-120"/>
               </a:rPr>
-              <a:t>▶  [ add demo video link ]</a:t>
+              <a:t>▶  https://youtu.be/oSdFeM6pjW8</a:t>
             </a:r>
             <a:endParaRPr lang="en-US" sz="1200" dirty="0"/>
           </a:p>
@@ -9355,7 +9355,7 @@
                 <a:ea typeface="Segoe UI" pitchFamily="34" charset="-122"/>
                 <a:cs typeface="Segoe UI" pitchFamily="34" charset="-120"/>
               </a:rPr>
-              <a:t>Tip: record a 1080p screen capture of the buggy-PR → blocked-merge flow + the dashboard.</a:t>
+              <a:t>Live demo: https://devguardian.onrender.com/dashboard</a:t>
             </a:r>
             <a:endParaRPr lang="en-US" sz="1000" dirty="0"/>
           </a:p>

</xml_diff>